<commit_message>
Format hymn lyrics and improve layout
- Remove ending punctuation from lyrics lines
- Replace middle punctuation with two spaces for cleaner display
- Adjust hymn_lyrics layout: larger font (76pt), more top margin, 140% line spacing
</commit_message>
<xml_diff>
--- a/mvccc_master_keynote_blue.pptx
+++ b/mvccc_master_keynote_blue.pptx
@@ -621,8 +621,8 @@
         </p:nvSpPr>
         <p:spPr>
           <a:xfrm>
-            <a:off x="406400" y="589901"/>
-            <a:ext cx="11379200" cy="5678198"/>
+            <a:off x="406400" y="914400"/>
+            <a:ext cx="11379200" cy="5353699"/>
           </a:xfrm>
           <a:prstGeom prst="rect">
             <a:avLst/>
@@ -632,7 +632,7 @@
           <a:bodyPr/>
           <a:lstStyle>
             <a:lvl1pPr algn="ctr">
-              <a:defRPr sz="7200"/>
+              <a:defRPr sz="7600"/>
             </a:lvl1pPr>
           </a:lstStyle>
           <a:p>

</xml_diff>

<commit_message>
increase the teaching slide
</commit_message>
<xml_diff>
--- a/mvccc_master_keynote_blue.pptx
+++ b/mvccc_master_keynote_blue.pptx
@@ -719,7 +719,7 @@
               <a:spcBef>
                 <a:spcPts val="400"/>
               </a:spcBef>
-              <a:defRPr sz="6336">
+              <a:defRPr sz="7200">
                 <a:effectLst>
                   <a:outerShdw sx="100000" sy="100000" kx="0" ky="0" algn="b" rotWithShape="0" blurRad="37719" dist="37719" dir="2700000">
                     <a:srgbClr val="0B0F14"/>
@@ -1043,7 +1043,7 @@
           <ns1:bodyPr/>
           <ns1:lstStyle>
             <ns1:lvl1pPr>
-              <ns1:defRPr b="1" sz="5200">
+              <ns1:defRPr b="1" sz="6000">
                 <ns1:latin typeface="Helvetica Neue"/>
                 <ns1:ea typeface="Helvetica Neue"/>
                 <ns1:cs typeface="Helvetica Neue"/>
@@ -1080,7 +1080,7 @@
           <ns1:bodyPr/>
           <ns1:lstStyle>
             <ns1:lvl1pPr algn="ctr">
-              <ns1:defRPr sz="4000">
+              <ns1:defRPr sz="4800">
                 <ns1:latin typeface="Helvetica Neue"/>
                 <ns1:ea typeface="Helvetica Neue"/>
                 <ns1:cs typeface="Helvetica Neue"/>
@@ -1611,7 +1611,7 @@
         <a:buFontTx/>
         <a:buNone/>
         <a:tabLst/>
-        <a:defRPr b="0" baseline="0" cap="none" i="0" spc="0" strike="noStrike" sz="6400" u="none">
+        <a:defRPr b="0" baseline="0" cap="none" i="0" spc="0" strike="noStrike" sz="7200" u="none">
           <a:solidFill>
             <a:schemeClr val="accent6"/>
           </a:solidFill>

</xml_diff>